<commit_message>
Restore Aristotle quote to closing slide of special lecture 3
Co-Authored-By: Claude Opus 5.5 <noreply@anthropic.com>
Claude-Session: https://claude.ai/code/session_01XYJ4xmrADRJAP7ufCAYieX
</commit_message>
<xml_diff>
--- a/special-lectures/special03_virtues_for_the_data_analyst.pptx
+++ b/special-lectures/special03_virtues_for_the_data_analyst.pptx
@@ -928,7 +928,7 @@
           <a:lstStyle/>
           <a:p>
             <a:r>
-              <a:t>Earlier in the course we said that all data problems are human problems. The other side is that all data needs are human needs. Behind every request is a person trying to make a decision. AI can supply capability, but virtue, in Aristotle's sense of a human excellence built through practice, is something only people bring. Courage, wisdom, justice and restraint are what make an analyst worth keeping in the loop. Like any virtue, they grow by practicing them, project by project.</a:t>
+              <a:t>Earlier in the course we said that all data problems are human problems. The other side is that all data needs are human needs. Behind every request is a person trying to make a decision. AI can supply capability, but not character. As Aristotle put it, virtue is a human thing: an excellence built through practice, and something only people bring. Courage, wisdom, justice and restraint are what make an analyst worth keeping in the loop. Like any virtue, they grow by practicing them, project by project.</a:t>
             </a:r>
           </a:p>
         </p:txBody>
@@ -1648,7 +1648,7 @@
 </p:sldMaster>
 </file>
 
-<file path=ppt/slides/slide11.xml><?xml version="1.0" encoding="utf-8"?>
+<file path=ppt/slides/slide1.xml><?xml version="1.0" encoding="utf-8"?>
 <p:sld xmlns:a="http://schemas.openxmlformats.org/drawingml/2006/main" xmlns:p="http://schemas.openxmlformats.org/presentationml/2006/main" xmlns:r="http://schemas.openxmlformats.org/officeDocument/2006/relationships">
   <p:cSld>
     <p:spTree>
@@ -1742,7 +1742,7 @@
 </p:sld>
 </file>
 
-<file path=ppt/slides/slide12.xml><?xml version="1.0" encoding="utf-8"?>
+<file path=ppt/slides/slide2.xml><?xml version="1.0" encoding="utf-8"?>
 <p:sld xmlns:a="http://schemas.openxmlformats.org/drawingml/2006/main" xmlns:p="http://schemas.openxmlformats.org/presentationml/2006/main" xmlns:r="http://schemas.openxmlformats.org/officeDocument/2006/relationships">
   <p:cSld>
     <p:spTree>
@@ -1939,7 +1939,7 @@
 </p:sld>
 </file>
 
-<file path=ppt/slides/slide13.xml><?xml version="1.0" encoding="utf-8"?>
+<file path=ppt/slides/slide3.xml><?xml version="1.0" encoding="utf-8"?>
 <p:sld xmlns:a="http://schemas.openxmlformats.org/drawingml/2006/main" xmlns:p="http://schemas.openxmlformats.org/presentationml/2006/main" xmlns:r="http://schemas.openxmlformats.org/officeDocument/2006/relationships">
   <p:cSld>
     <p:spTree>
@@ -2136,7 +2136,7 @@
 </p:sld>
 </file>
 
-<file path=ppt/slides/slide14.xml><?xml version="1.0" encoding="utf-8"?>
+<file path=ppt/slides/slide4.xml><?xml version="1.0" encoding="utf-8"?>
 <p:sld xmlns:a="http://schemas.openxmlformats.org/drawingml/2006/main" xmlns:p="http://schemas.openxmlformats.org/presentationml/2006/main" xmlns:r="http://schemas.openxmlformats.org/officeDocument/2006/relationships">
   <p:cSld>
     <p:spTree>
@@ -2333,7 +2333,7 @@
 </p:sld>
 </file>
 
-<file path=ppt/slides/slide15.xml><?xml version="1.0" encoding="utf-8"?>
+<file path=ppt/slides/slide5.xml><?xml version="1.0" encoding="utf-8"?>
 <p:sld xmlns:a="http://schemas.openxmlformats.org/drawingml/2006/main" xmlns:p="http://schemas.openxmlformats.org/presentationml/2006/main" xmlns:r="http://schemas.openxmlformats.org/officeDocument/2006/relationships">
   <p:cSld>
     <p:spTree>
@@ -2530,7 +2530,7 @@
 </p:sld>
 </file>
 
-<file path=ppt/slides/slide16.xml><?xml version="1.0" encoding="utf-8"?>
+<file path=ppt/slides/slide6.xml><?xml version="1.0" encoding="utf-8"?>
 <p:sld xmlns:a="http://schemas.openxmlformats.org/drawingml/2006/main" xmlns:p="http://schemas.openxmlformats.org/presentationml/2006/main" xmlns:r="http://schemas.openxmlformats.org/officeDocument/2006/relationships">
   <p:cSld>
     <p:spTree>
@@ -2727,7 +2727,7 @@
 </p:sld>
 </file>
 
-<file path=ppt/slides/slide17.xml><?xml version="1.0" encoding="utf-8"?>
+<file path=ppt/slides/slide7.xml><?xml version="1.0" encoding="utf-8"?>
 <p:sld xmlns:a="http://schemas.openxmlformats.org/drawingml/2006/main" xmlns:p="http://schemas.openxmlformats.org/presentationml/2006/main" xmlns:r="http://schemas.openxmlformats.org/officeDocument/2006/relationships">
   <p:cSld>
     <p:spTree>
@@ -2847,7 +2847,7 @@
                   <a:srgbClr val="FFFFFF"/>
                 </a:solidFill>
               </a:rPr>
-              <a:t>AI can supply capability; virtue is a human excellence</a:t>
+              <a:t>AI can supply capability, but not character</a:t>
             </a:r>
             <a:endParaRPr lang="en-US" sz="2400" dirty="0"/>
           </a:p>
@@ -2865,7 +2865,7 @@
                   <a:srgbClr val="FFFFFF"/>
                 </a:solidFill>
               </a:rPr>
-              <a:t>Practice these virtues on every project</a:t>
+              <a:t>“Virtue is a human thing” – Aristotle</a:t>
             </a:r>
             <a:endParaRPr lang="en-US" sz="2400" dirty="0"/>
           </a:p>
@@ -2924,7 +2924,7 @@
 </p:sld>
 </file>
 
-<file path=ppt/slides/slide18.xml><?xml version="1.0" encoding="utf-8"?>
+<file path=ppt/slides/slide8.xml><?xml version="1.0" encoding="utf-8"?>
 <p:sld xmlns:a="http://schemas.openxmlformats.org/drawingml/2006/main" xmlns:p="http://schemas.openxmlformats.org/presentationml/2006/main" xmlns:r="http://schemas.openxmlformats.org/officeDocument/2006/relationships">
   <p:cSld>
     <p:spTree>

</xml_diff>

<commit_message>
Refocus special lecture 3 conclusion on the Aristotle quote
Co-Authored-By: Claude Opus 5.5 <noreply@anthropic.com>
Claude-Session: https://claude.ai/code/session_01XYJ4xmrADRJAP7ufCAYieX
</commit_message>
<xml_diff>
--- a/special-lectures/special03_virtues_for_the_data_analyst.pptx
+++ b/special-lectures/special03_virtues_for_the_data_analyst.pptx
@@ -928,7 +928,7 @@
           <a:lstStyle/>
           <a:p>
             <a:r>
-              <a:t>Earlier in the course we said that all data problems are human problems. The other side is that all data needs are human needs. Behind every request is a person trying to make a decision. AI can supply capability, but not character. As Aristotle put it, virtue is a human thing: an excellence built through practice, and something only people bring. Courage, wisdom, justice and restraint are what make an analyst worth keeping in the loop. Like any virtue, they grow by practicing them, project by project.</a:t>
+              <a:t>I want to close with a line from Aristotle: virtue is a human thing. AI tools will keep getting more capable. They can write the code, run the model and draft the report, and in many cases they will match or beat an analyst on raw capability. What they can't supply is character. For Aristotle, a virtue isn't something you're born with or something you can download. It's an excellence you build by practicing it until it becomes part of who you are. You become courageous by doing courageous things, and just by doing just things. That's why these four virtues are where an analyst's lasting value comes from. Clients keep coming back to the analyst who takes on the hard problem, knows what matters, tells the truth about the numbers and stays focused on what they need. So don't treat this as a list to memorize. Pick one virtue, the one that comes hardest to you, and practice it deliberately on your next project. That's how a technical professional becomes a trusted one.</a:t>
             </a:r>
           </a:p>
         </p:txBody>
@@ -2769,7 +2769,7 @@
                   <a:srgbClr val="FFFFFF"/>
                 </a:solidFill>
               </a:rPr>
-              <a:t>All data needs are human needs</a:t>
+              <a:t>“Virtue is a human thing” – Aristotle</a:t>
             </a:r>
             <a:endParaRPr lang="en-US" sz="3200" dirty="0"/>
           </a:p>
@@ -2811,7 +2811,7 @@
                   <a:srgbClr val="FFFFFF"/>
                 </a:solidFill>
               </a:rPr>
-              <a:t>All data problems are human problems</a:t>
+              <a:t>AI can match an analyst's capability, not their character</a:t>
             </a:r>
             <a:endParaRPr lang="en-US" sz="2400" dirty="0"/>
           </a:p>
@@ -2829,7 +2829,7 @@
                   <a:srgbClr val="FFFFFF"/>
                 </a:solidFill>
               </a:rPr>
-              <a:t>All data needs are human needs</a:t>
+              <a:t>Virtues are built by people, through practice</a:t>
             </a:r>
             <a:endParaRPr lang="en-US" sz="2400" dirty="0"/>
           </a:p>
@@ -2847,7 +2847,7 @@
                   <a:srgbClr val="FFFFFF"/>
                 </a:solidFill>
               </a:rPr>
-              <a:t>AI can supply capability, but not character</a:t>
+              <a:t>Clients trust analysts who show courage, wisdom, justice and restraint</a:t>
             </a:r>
             <a:endParaRPr lang="en-US" sz="2400" dirty="0"/>
           </a:p>
@@ -2865,7 +2865,7 @@
                   <a:srgbClr val="FFFFFF"/>
                 </a:solidFill>
               </a:rPr>
-              <a:t>“Virtue is a human thing” – Aristotle</a:t>
+              <a:t>Choose one virtue to practice on your next project</a:t>
             </a:r>
             <a:endParaRPr lang="en-US" sz="2400" dirty="0"/>
           </a:p>

</xml_diff>